<commit_message>
Use deployed Vercel URLs instead of localhost; fix overlapping text in presentation slides
</commit_message>
<xml_diff>
--- a/Stockedup_Project_Presentation.pptx
+++ b/Stockedup_Project_Presentation.pptx
@@ -1959,7 +1959,7 @@
         </p:blipFill>
         <p:spPr>
           <a:xfrm>
-            <a:off x="5477256" y="411480"/>
+            <a:off x="5477256" y="320040"/>
             <a:ext cx="1234440" cy="1042416"/>
           </a:xfrm>
           <a:prstGeom prst="rect">
@@ -1975,8 +1975,8 @@
         </p:nvSpPr>
         <p:spPr>
           <a:xfrm>
-            <a:off x="457200" y="1554480"/>
-            <a:ext cx="11274552" cy="914400"/>
+            <a:off x="457200" y="1417320"/>
+            <a:ext cx="11274552" cy="685800"/>
           </a:xfrm>
           <a:prstGeom prst="rect">
             <a:avLst/>
@@ -2014,8 +2014,8 @@
         </p:nvSpPr>
         <p:spPr>
           <a:xfrm>
-            <a:off x="457200" y="2395728"/>
-            <a:ext cx="11274552" cy="502920"/>
+            <a:off x="457200" y="2286000"/>
+            <a:ext cx="11274552" cy="457200"/>
           </a:xfrm>
           <a:prstGeom prst="rect">
             <a:avLst/>
@@ -2053,7 +2053,7 @@
         </p:nvSpPr>
         <p:spPr>
           <a:xfrm>
-            <a:off x="4727448" y="3063240"/>
+            <a:off x="4727448" y="2880360"/>
             <a:ext cx="2743200" cy="27432"/>
           </a:xfrm>
           <a:prstGeom prst="rect">
@@ -2073,8 +2073,8 @@
         </p:nvSpPr>
         <p:spPr>
           <a:xfrm>
-            <a:off x="457200" y="3200400"/>
-            <a:ext cx="11274552" cy="411480"/>
+            <a:off x="457200" y="3035808"/>
+            <a:ext cx="11274552" cy="384048"/>
           </a:xfrm>
           <a:prstGeom prst="rect">
             <a:avLst/>
@@ -2112,8 +2112,8 @@
         </p:nvSpPr>
         <p:spPr>
           <a:xfrm>
-            <a:off x="2441448" y="3794760"/>
-            <a:ext cx="7315200" cy="1645920"/>
+            <a:off x="2441448" y="3611880"/>
+            <a:ext cx="7315200" cy="1691640"/>
           </a:xfrm>
           <a:prstGeom prst="rect">
             <a:avLst/>
@@ -2127,7 +2127,7 @@
           <a:p>
             <a:pPr algn="ctr" indent="0" marL="0">
               <a:lnSpc>
-                <a:spcPts val="800"/>
+                <a:spcPts val="2600"/>
               </a:lnSpc>
               <a:buNone/>
             </a:pPr>
@@ -2144,21 +2144,29 @@
             </a:r>
             <a:pPr algn="ctr" indent="0" marL="0">
               <a:lnSpc>
-                <a:spcPts val="800"/>
+                <a:spcPts val="2600"/>
               </a:lnSpc>
               <a:buNone/>
             </a:pPr>
-            <a:endParaRPr lang="en-US" sz="1300" dirty="0"/>
-          </a:p>
-          <a:p>
+            <a:r>
+              <a:rPr lang="en-US" sz="1600" b="1" dirty="0">
+                <a:solidFill>
+                  <a:srgbClr val="1A1A1A"/>
+                </a:solidFill>
+                <a:latin typeface="Calibri" pitchFamily="34" charset="0"/>
+                <a:ea typeface="Calibri" pitchFamily="34" charset="-122"/>
+                <a:cs typeface="Calibri" pitchFamily="34" charset="-120"/>
+              </a:rPr>
+              <a:t>Group Leader:  Shubham Kr. Mandal</a:t>
+            </a:r>
             <a:pPr algn="ctr" indent="0" marL="0">
               <a:lnSpc>
-                <a:spcPts val="800"/>
+                <a:spcPts val="2600"/>
               </a:lnSpc>
               <a:buNone/>
             </a:pPr>
             <a:r>
-              <a:rPr lang="en-US" sz="1600" b="1" dirty="0">
+              <a:rPr lang="en-US" sz="1600" dirty="0">
                 <a:solidFill>
                   <a:srgbClr val="1A1A1A"/>
                 </a:solidFill>
@@ -2166,52 +2174,11 @@
                 <a:ea typeface="Calibri" pitchFamily="34" charset="-122"/>
                 <a:cs typeface="Calibri" pitchFamily="34" charset="-120"/>
               </a:rPr>
-              <a:t>Group Leader:  Shubham Kr. Mandal</a:t>
-            </a:r>
-            <a:endParaRPr lang="en-US" sz="1300" dirty="0"/>
-          </a:p>
-          <a:p>
+              <a:t>Members:  Aditya Raj (Regd. No. 2501445017)</a:t>
+            </a:r>
             <a:pPr algn="ctr" indent="0" marL="0">
               <a:lnSpc>
-                <a:spcPts val="800"/>
-              </a:lnSpc>
-              <a:buNone/>
-            </a:pPr>
-            <a:endParaRPr lang="en-US" sz="1300" dirty="0"/>
-          </a:p>
-          <a:p>
-            <a:pPr algn="ctr" indent="0" marL="0">
-              <a:lnSpc>
-                <a:spcPts val="800"/>
-              </a:lnSpc>
-              <a:buNone/>
-            </a:pPr>
-            <a:r>
-              <a:rPr lang="en-US" sz="1600" dirty="0">
-                <a:solidFill>
-                  <a:srgbClr val="1A1A1A"/>
-                </a:solidFill>
-                <a:latin typeface="Calibri" pitchFamily="34" charset="0"/>
-                <a:ea typeface="Calibri" pitchFamily="34" charset="-122"/>
-                <a:cs typeface="Calibri" pitchFamily="34" charset="-120"/>
-              </a:rPr>
-              <a:t>Members:  Aditya Raj (Regd. No. 2501445017)</a:t>
-            </a:r>
-            <a:endParaRPr lang="en-US" sz="1300" dirty="0"/>
-          </a:p>
-          <a:p>
-            <a:pPr algn="ctr" indent="0" marL="0">
-              <a:lnSpc>
-                <a:spcPts val="800"/>
-              </a:lnSpc>
-              <a:buNone/>
-            </a:pPr>
-            <a:endParaRPr lang="en-US" sz="1300" dirty="0"/>
-          </a:p>
-          <a:p>
-            <a:pPr algn="ctr" indent="0" marL="0">
-              <a:lnSpc>
-                <a:spcPts val="800"/>
+                <a:spcPts val="2600"/>
               </a:lnSpc>
               <a:buNone/>
             </a:pPr>
@@ -2314,7 +2281,7 @@
         </p:nvSpPr>
         <p:spPr>
           <a:xfrm>
-            <a:off x="457200" y="5532120"/>
+            <a:off x="457200" y="5504688"/>
             <a:ext cx="11274552" cy="365760"/>
           </a:xfrm>
           <a:prstGeom prst="rect">
@@ -3297,8 +3264,8 @@
         </p:nvSpPr>
         <p:spPr>
           <a:xfrm>
-            <a:off x="457200" y="1920240"/>
-            <a:ext cx="11274552" cy="822960"/>
+            <a:off x="457200" y="1828800"/>
+            <a:ext cx="11274552" cy="731520"/>
           </a:xfrm>
           <a:prstGeom prst="rect">
             <a:avLst/>
@@ -3336,7 +3303,7 @@
         </p:nvSpPr>
         <p:spPr>
           <a:xfrm>
-            <a:off x="457200" y="2697480"/>
+            <a:off x="457200" y="2724912"/>
             <a:ext cx="11274552" cy="457200"/>
           </a:xfrm>
           <a:prstGeom prst="rect">
@@ -3375,8 +3342,8 @@
         </p:nvSpPr>
         <p:spPr>
           <a:xfrm>
-            <a:off x="1828800" y="3474720"/>
-            <a:ext cx="8531352" cy="1371600"/>
+            <a:off x="1828800" y="3566160"/>
+            <a:ext cx="8531352" cy="1463040"/>
           </a:xfrm>
           <a:prstGeom prst="rect">
             <a:avLst/>
@@ -3390,7 +3357,7 @@
           <a:p>
             <a:pPr algn="ctr" indent="0" marL="0">
               <a:lnSpc>
-                <a:spcPts val="1000"/>
+                <a:spcPts val="2600"/>
               </a:lnSpc>
               <a:buNone/>
             </a:pPr>
@@ -3407,16 +3374,7 @@
             </a:r>
             <a:pPr algn="ctr" indent="0" marL="0">
               <a:lnSpc>
-                <a:spcPts val="1000"/>
-              </a:lnSpc>
-              <a:buNone/>
-            </a:pPr>
-            <a:endParaRPr lang="en-US" sz="1500" dirty="0"/>
-          </a:p>
-          <a:p>
-            <a:pPr algn="ctr" indent="0" marL="0">
-              <a:lnSpc>
-                <a:spcPts val="1000"/>
+                <a:spcPts val="2600"/>
               </a:lnSpc>
               <a:buNone/>
             </a:pPr>
@@ -6834,7 +6792,7 @@
           <a:p>
             <a:pPr indent="0" marL="0">
               <a:lnSpc>
-                <a:spcPts val="600"/>
+                <a:spcPts val="1800"/>
               </a:lnSpc>
               <a:buNone/>
             </a:pPr>
@@ -6854,7 +6812,7 @@
           <a:p>
             <a:pPr indent="0" marL="0">
               <a:lnSpc>
-                <a:spcPts val="600"/>
+                <a:spcPts val="1800"/>
               </a:lnSpc>
               <a:buNone/>
             </a:pPr>
@@ -6874,7 +6832,7 @@
           <a:p>
             <a:pPr indent="0" marL="0">
               <a:lnSpc>
-                <a:spcPts val="600"/>
+                <a:spcPts val="1800"/>
               </a:lnSpc>
               <a:buNone/>
             </a:pPr>
@@ -7003,7 +6961,7 @@
           <a:p>
             <a:pPr indent="0" marL="0">
               <a:lnSpc>
-                <a:spcPts val="600"/>
+                <a:spcPts val="1800"/>
               </a:lnSpc>
               <a:buNone/>
             </a:pPr>
@@ -7023,7 +6981,7 @@
           <a:p>
             <a:pPr indent="0" marL="0">
               <a:lnSpc>
-                <a:spcPts val="600"/>
+                <a:spcPts val="1800"/>
               </a:lnSpc>
               <a:buNone/>
             </a:pPr>
@@ -7043,7 +7001,7 @@
           <a:p>
             <a:pPr indent="0" marL="0">
               <a:lnSpc>
-                <a:spcPts val="600"/>
+                <a:spcPts val="1800"/>
               </a:lnSpc>
               <a:buNone/>
             </a:pPr>
@@ -7149,7 +7107,7 @@
           <a:p>
             <a:pPr indent="0" marL="0">
               <a:lnSpc>
-                <a:spcPts val="600"/>
+                <a:spcPts val="1800"/>
               </a:lnSpc>
               <a:buNone/>
             </a:pPr>
@@ -7169,7 +7127,7 @@
           <a:p>
             <a:pPr indent="0" marL="0">
               <a:lnSpc>
-                <a:spcPts val="600"/>
+                <a:spcPts val="1800"/>
               </a:lnSpc>
               <a:buNone/>
             </a:pPr>
@@ -7189,7 +7147,7 @@
           <a:p>
             <a:pPr indent="0" marL="0">
               <a:lnSpc>
-                <a:spcPts val="600"/>
+                <a:spcPts val="1800"/>
               </a:lnSpc>
               <a:buNone/>
             </a:pPr>
@@ -7318,7 +7276,7 @@
           <a:p>
             <a:pPr indent="0" marL="0">
               <a:lnSpc>
-                <a:spcPts val="600"/>
+                <a:spcPts val="1800"/>
               </a:lnSpc>
               <a:buNone/>
             </a:pPr>
@@ -7338,7 +7296,7 @@
           <a:p>
             <a:pPr indent="0" marL="0">
               <a:lnSpc>
-                <a:spcPts val="600"/>
+                <a:spcPts val="1800"/>
               </a:lnSpc>
               <a:buNone/>
             </a:pPr>
@@ -7358,7 +7316,7 @@
           <a:p>
             <a:pPr indent="0" marL="0">
               <a:lnSpc>
-                <a:spcPts val="600"/>
+                <a:spcPts val="1800"/>
               </a:lnSpc>
               <a:buNone/>
             </a:pPr>

</xml_diff>

<commit_message>
Add Chanchal Patar (Regd. No. 2501445488) to presentation team slides
</commit_message>
<xml_diff>
--- a/Stockedup_Project_Presentation.pptx
+++ b/Stockedup_Project_Presentation.pptx
@@ -2112,8 +2112,8 @@
         </p:nvSpPr>
         <p:spPr>
           <a:xfrm>
-            <a:off x="2441448" y="3611880"/>
-            <a:ext cx="7315200" cy="1691640"/>
+            <a:off x="2441448" y="3566160"/>
+            <a:ext cx="7315200" cy="347472"/>
           </a:xfrm>
           <a:prstGeom prst="rect">
             <a:avLst/>
@@ -2126,9 +2126,6 @@
           <a:lstStyle/>
           <a:p>
             <a:pPr algn="ctr" indent="0" marL="0">
-              <a:lnSpc>
-                <a:spcPts val="2600"/>
-              </a:lnSpc>
               <a:buNone/>
             </a:pPr>
             <a:r>
@@ -2142,10 +2139,32 @@
               </a:rPr>
               <a:t>Presented by</a:t>
             </a:r>
+            <a:endParaRPr lang="en-US" sz="1300" dirty="0"/>
+          </a:p>
+        </p:txBody>
+      </p:sp>
+      <p:sp>
+        <p:nvSpPr>
+          <p:cNvPr id="8" name="Text 5"/>
+          <p:cNvSpPr/>
+          <p:nvPr/>
+        </p:nvSpPr>
+        <p:spPr>
+          <a:xfrm>
+            <a:off x="2441448" y="3913632"/>
+            <a:ext cx="7315200" cy="347472"/>
+          </a:xfrm>
+          <a:prstGeom prst="rect">
+            <a:avLst/>
+          </a:prstGeom>
+          <a:noFill/>
+          <a:ln/>
+        </p:spPr>
+        <p:txBody>
+          <a:bodyPr wrap="square" rtlCol="0" anchor="ctr"/>
+          <a:lstStyle/>
+          <a:p>
             <a:pPr algn="ctr" indent="0" marL="0">
-              <a:lnSpc>
-                <a:spcPts val="2600"/>
-              </a:lnSpc>
               <a:buNone/>
             </a:pPr>
             <a:r>
@@ -2159,10 +2178,32 @@
               </a:rPr>
               <a:t>Group Leader:  Shubham Kr. Mandal</a:t>
             </a:r>
+            <a:endParaRPr lang="en-US" sz="1600" dirty="0"/>
+          </a:p>
+        </p:txBody>
+      </p:sp>
+      <p:sp>
+        <p:nvSpPr>
+          <p:cNvPr id="9" name="Text 6"/>
+          <p:cNvSpPr/>
+          <p:nvPr/>
+        </p:nvSpPr>
+        <p:spPr>
+          <a:xfrm>
+            <a:off x="2441448" y="4261104"/>
+            <a:ext cx="7315200" cy="347472"/>
+          </a:xfrm>
+          <a:prstGeom prst="rect">
+            <a:avLst/>
+          </a:prstGeom>
+          <a:noFill/>
+          <a:ln/>
+        </p:spPr>
+        <p:txBody>
+          <a:bodyPr wrap="square" rtlCol="0" anchor="ctr"/>
+          <a:lstStyle/>
+          <a:p>
             <a:pPr algn="ctr" indent="0" marL="0">
-              <a:lnSpc>
-                <a:spcPts val="2600"/>
-              </a:lnSpc>
               <a:buNone/>
             </a:pPr>
             <a:r>
@@ -2176,10 +2217,32 @@
               </a:rPr>
               <a:t>Members:  Aditya Raj (Regd. No. 2501445017)</a:t>
             </a:r>
+            <a:endParaRPr lang="en-US" sz="1600" dirty="0"/>
+          </a:p>
+        </p:txBody>
+      </p:sp>
+      <p:sp>
+        <p:nvSpPr>
+          <p:cNvPr id="10" name="Text 7"/>
+          <p:cNvSpPr/>
+          <p:nvPr/>
+        </p:nvSpPr>
+        <p:spPr>
+          <a:xfrm>
+            <a:off x="2441448" y="4608576"/>
+            <a:ext cx="7315200" cy="347472"/>
+          </a:xfrm>
+          <a:prstGeom prst="rect">
+            <a:avLst/>
+          </a:prstGeom>
+          <a:noFill/>
+          <a:ln/>
+        </p:spPr>
+        <p:txBody>
+          <a:bodyPr wrap="square" rtlCol="0" anchor="ctr"/>
+          <a:lstStyle/>
+          <a:p>
             <a:pPr algn="ctr" indent="0" marL="0">
-              <a:lnSpc>
-                <a:spcPts val="2600"/>
-              </a:lnSpc>
               <a:buNone/>
             </a:pPr>
             <a:r>
@@ -2193,13 +2256,52 @@
               </a:rPr>
               <a:t>Rudra Narayan Barik (Regd. No. 2501445603)</a:t>
             </a:r>
-            <a:endParaRPr lang="en-US" sz="1300" dirty="0"/>
-          </a:p>
-        </p:txBody>
-      </p:sp>
-      <p:sp>
-        <p:nvSpPr>
-          <p:cNvPr id="8" name="Shape 5"/>
+            <a:endParaRPr lang="en-US" sz="1600" dirty="0"/>
+          </a:p>
+        </p:txBody>
+      </p:sp>
+      <p:sp>
+        <p:nvSpPr>
+          <p:cNvPr id="11" name="Text 8"/>
+          <p:cNvSpPr/>
+          <p:nvPr/>
+        </p:nvSpPr>
+        <p:spPr>
+          <a:xfrm>
+            <a:off x="2441448" y="4956048"/>
+            <a:ext cx="7315200" cy="347472"/>
+          </a:xfrm>
+          <a:prstGeom prst="rect">
+            <a:avLst/>
+          </a:prstGeom>
+          <a:noFill/>
+          <a:ln/>
+        </p:spPr>
+        <p:txBody>
+          <a:bodyPr wrap="square" rtlCol="0" anchor="ctr"/>
+          <a:lstStyle/>
+          <a:p>
+            <a:pPr algn="ctr" indent="0" marL="0">
+              <a:buNone/>
+            </a:pPr>
+            <a:r>
+              <a:rPr lang="en-US" sz="1600" dirty="0">
+                <a:solidFill>
+                  <a:srgbClr val="1A1A1A"/>
+                </a:solidFill>
+                <a:latin typeface="Calibri" pitchFamily="34" charset="0"/>
+                <a:ea typeface="Calibri" pitchFamily="34" charset="-122"/>
+                <a:cs typeface="Calibri" pitchFamily="34" charset="-120"/>
+              </a:rPr>
+              <a:t>Chanchal Patar (Regd. No. 2501445488)</a:t>
+            </a:r>
+            <a:endParaRPr lang="en-US" sz="1600" dirty="0"/>
+          </a:p>
+        </p:txBody>
+      </p:sp>
+      <p:sp>
+        <p:nvSpPr>
+          <p:cNvPr id="12" name="Shape 9"/>
           <p:cNvSpPr/>
           <p:nvPr/>
         </p:nvSpPr>
@@ -2219,7 +2321,7 @@
       </p:sp>
       <p:sp>
         <p:nvSpPr>
-          <p:cNvPr id="9" name="Text 6"/>
+          <p:cNvPr id="13" name="Text 10"/>
           <p:cNvSpPr/>
           <p:nvPr/>
         </p:nvSpPr>
@@ -2275,7 +2377,7 @@
       </p:sp>
       <p:sp>
         <p:nvSpPr>
-          <p:cNvPr id="10" name="Text 7"/>
+          <p:cNvPr id="14" name="Text 11"/>
           <p:cNvSpPr/>
           <p:nvPr/>
         </p:nvSpPr>
@@ -3342,8 +3444,8 @@
         </p:nvSpPr>
         <p:spPr>
           <a:xfrm>
-            <a:off x="1828800" y="3566160"/>
-            <a:ext cx="8531352" cy="1463040"/>
+            <a:off x="1828800" y="3520440"/>
+            <a:ext cx="8531352" cy="365760"/>
           </a:xfrm>
           <a:prstGeom prst="rect">
             <a:avLst/>
@@ -3356,9 +3458,6 @@
           <a:lstStyle/>
           <a:p>
             <a:pPr algn="ctr" indent="0" marL="0">
-              <a:lnSpc>
-                <a:spcPts val="2600"/>
-              </a:lnSpc>
               <a:buNone/>
             </a:pPr>
             <a:r>
@@ -3372,10 +3471,32 @@
               </a:rPr>
               <a:t>Group Leader: Shubham Kr. Mandal</a:t>
             </a:r>
+            <a:endParaRPr lang="en-US" sz="1500" dirty="0"/>
+          </a:p>
+        </p:txBody>
+      </p:sp>
+      <p:sp>
+        <p:nvSpPr>
+          <p:cNvPr id="7" name="Text 4"/>
+          <p:cNvSpPr/>
+          <p:nvPr/>
+        </p:nvSpPr>
+        <p:spPr>
+          <a:xfrm>
+            <a:off x="1828800" y="3913632"/>
+            <a:ext cx="8531352" cy="365760"/>
+          </a:xfrm>
+          <a:prstGeom prst="rect">
+            <a:avLst/>
+          </a:prstGeom>
+          <a:noFill/>
+          <a:ln/>
+        </p:spPr>
+        <p:txBody>
+          <a:bodyPr wrap="square" rtlCol="0" anchor="ctr"/>
+          <a:lstStyle/>
+          <a:p>
             <a:pPr algn="ctr" indent="0" marL="0">
-              <a:lnSpc>
-                <a:spcPts val="2600"/>
-              </a:lnSpc>
               <a:buNone/>
             </a:pPr>
             <a:r>
@@ -3387,7 +3508,7 @@
                 <a:ea typeface="Calibri" pitchFamily="34" charset="-122"/>
                 <a:cs typeface="Calibri" pitchFamily="34" charset="-120"/>
               </a:rPr>
-              <a:t>Members: Aditya Raj (Regd. No. 2501445017)   |   Rudra Narayan Barik (Regd. No. 2501445603)</a:t>
+              <a:t>Members: Aditya Raj (Regd. No. 2501445017)</a:t>
             </a:r>
             <a:endParaRPr lang="en-US" sz="1500" dirty="0"/>
           </a:p>
@@ -3395,7 +3516,85 @@
       </p:sp>
       <p:sp>
         <p:nvSpPr>
-          <p:cNvPr id="7" name="Shape 4"/>
+          <p:cNvPr id="8" name="Text 5"/>
+          <p:cNvSpPr/>
+          <p:nvPr/>
+        </p:nvSpPr>
+        <p:spPr>
+          <a:xfrm>
+            <a:off x="1828800" y="4261104"/>
+            <a:ext cx="8531352" cy="365760"/>
+          </a:xfrm>
+          <a:prstGeom prst="rect">
+            <a:avLst/>
+          </a:prstGeom>
+          <a:noFill/>
+          <a:ln/>
+        </p:spPr>
+        <p:txBody>
+          <a:bodyPr wrap="square" rtlCol="0" anchor="ctr"/>
+          <a:lstStyle/>
+          <a:p>
+            <a:pPr algn="ctr" indent="0" marL="0">
+              <a:buNone/>
+            </a:pPr>
+            <a:r>
+              <a:rPr lang="en-US" sz="1500" dirty="0">
+                <a:solidFill>
+                  <a:srgbClr val="1A1A1A"/>
+                </a:solidFill>
+                <a:latin typeface="Calibri" pitchFamily="34" charset="0"/>
+                <a:ea typeface="Calibri" pitchFamily="34" charset="-122"/>
+                <a:cs typeface="Calibri" pitchFamily="34" charset="-120"/>
+              </a:rPr>
+              <a:t>Rudra Narayan Barik (Regd. No. 2501445603)</a:t>
+            </a:r>
+            <a:endParaRPr lang="en-US" sz="1500" dirty="0"/>
+          </a:p>
+        </p:txBody>
+      </p:sp>
+      <p:sp>
+        <p:nvSpPr>
+          <p:cNvPr id="9" name="Text 6"/>
+          <p:cNvSpPr/>
+          <p:nvPr/>
+        </p:nvSpPr>
+        <p:spPr>
+          <a:xfrm>
+            <a:off x="1828800" y="4608576"/>
+            <a:ext cx="8531352" cy="365760"/>
+          </a:xfrm>
+          <a:prstGeom prst="rect">
+            <a:avLst/>
+          </a:prstGeom>
+          <a:noFill/>
+          <a:ln/>
+        </p:spPr>
+        <p:txBody>
+          <a:bodyPr wrap="square" rtlCol="0" anchor="ctr"/>
+          <a:lstStyle/>
+          <a:p>
+            <a:pPr algn="ctr" indent="0" marL="0">
+              <a:buNone/>
+            </a:pPr>
+            <a:r>
+              <a:rPr lang="en-US" sz="1500" dirty="0">
+                <a:solidFill>
+                  <a:srgbClr val="1A1A1A"/>
+                </a:solidFill>
+                <a:latin typeface="Calibri" pitchFamily="34" charset="0"/>
+                <a:ea typeface="Calibri" pitchFamily="34" charset="-122"/>
+                <a:cs typeface="Calibri" pitchFamily="34" charset="-120"/>
+              </a:rPr>
+              <a:t>Chanchal Patar (Regd. No. 2501445488)</a:t>
+            </a:r>
+            <a:endParaRPr lang="en-US" sz="1500" dirty="0"/>
+          </a:p>
+        </p:txBody>
+      </p:sp>
+      <p:sp>
+        <p:nvSpPr>
+          <p:cNvPr id="10" name="Shape 7"/>
           <p:cNvSpPr/>
           <p:nvPr/>
         </p:nvSpPr>
@@ -3415,7 +3614,7 @@
       </p:sp>
       <p:sp>
         <p:nvSpPr>
-          <p:cNvPr id="8" name="Text 5"/>
+          <p:cNvPr id="11" name="Text 8"/>
           <p:cNvSpPr/>
           <p:nvPr/>
         </p:nvSpPr>

</xml_diff>

<commit_message>
Add Regd. No. 2501445245 for group leader in presentation team slides
</commit_message>
<xml_diff>
--- a/Stockedup_Project_Presentation.pptx
+++ b/Stockedup_Project_Presentation.pptx
@@ -2176,7 +2176,7 @@
                 <a:ea typeface="Calibri" pitchFamily="34" charset="-122"/>
                 <a:cs typeface="Calibri" pitchFamily="34" charset="-120"/>
               </a:rPr>
-              <a:t>Group Leader:  Shubham Kr. Mandal</a:t>
+              <a:t>Group Leader:  Shubham Kr. Mandal (Regd. No. 2501445245)</a:t>
             </a:r>
             <a:endParaRPr lang="en-US" sz="1600" dirty="0"/>
           </a:p>
@@ -3469,7 +3469,7 @@
                 <a:ea typeface="Calibri" pitchFamily="34" charset="-122"/>
                 <a:cs typeface="Calibri" pitchFamily="34" charset="-120"/>
               </a:rPr>
-              <a:t>Group Leader: Shubham Kr. Mandal</a:t>
+              <a:t>Group Leader: Shubham Kr. Mandal (Regd. No. 2501445245)</a:t>
             </a:r>
             <a:endParaRPr lang="en-US" sz="1500" dirty="0"/>
           </a:p>

</xml_diff>